<commit_message>
remove window files and update ppt
</commit_message>
<xml_diff>
--- a/An introduction to  OpenStudio & Energyplus.pptx
+++ b/An introduction to  OpenStudio & Energyplus.pptx
@@ -6469,7 +6469,7 @@
         <p:spPr>
           <a:xfrm>
             <a:off x="716692" y="1919072"/>
-            <a:ext cx="4794422" cy="4801314"/>
+            <a:ext cx="4794422" cy="4524315"/>
           </a:xfrm>
           <a:prstGeom prst="rect">
             <a:avLst/>
@@ -6503,23 +6503,18 @@
               <a:t>Dview</a:t>
             </a:r>
             <a:r>
-              <a:rPr lang="en-CA" dirty="0">
+              <a:rPr lang="en-CA">
                 <a:solidFill>
                   <a:srgbClr val="FF0000"/>
                 </a:solidFill>
               </a:rPr>
-              <a:t> and default libraries) </a:t>
-            </a:r>
-          </a:p>
-          <a:p>
-            <a:pPr marL="285750" indent="-285750">
-              <a:buFont typeface="Arial" panose="020B0604020202020204" pitchFamily="34" charset="0"/>
-              <a:buChar char="•"/>
-            </a:pPr>
-            <a:r>
-              <a:rPr lang="en-CA" dirty="0"/>
-              <a:t>Create a model </a:t>
-            </a:r>
+              <a:t>, default libraries, weather file) </a:t>
+            </a:r>
+            <a:endParaRPr lang="en-CA" dirty="0">
+              <a:solidFill>
+                <a:srgbClr val="FF0000"/>
+              </a:solidFill>
+            </a:endParaRPr>
           </a:p>
           <a:p>
             <a:pPr marL="285750" indent="-285750">
@@ -17480,6 +17475,23 @@
 </file>
 
 <file path=customXml/item1.xml><?xml version="1.0" encoding="utf-8"?>
+<?mso-contentType ?>
+<FormTemplates xmlns="http://schemas.microsoft.com/sharepoint/v3/contenttype/forms">
+  <Display>DocumentLibraryForm</Display>
+  <Edit>DocumentLibraryForm</Edit>
+  <New>DocumentLibraryForm</New>
+</FormTemplates>
+</file>
+
+<file path=customXml/item2.xml><?xml version="1.0" encoding="utf-8"?>
+<p:properties xmlns:p="http://schemas.microsoft.com/office/2006/metadata/properties" xmlns:xsi="http://www.w3.org/2001/XMLSchema-instance" xmlns:pc="http://schemas.microsoft.com/office/infopath/2007/PartnerControls">
+  <documentManagement>
+    <MediaServiceKeyPoints xmlns="71af3243-3dd4-4a8d-8c0d-dd76da1f02a5" xsi:nil="true"/>
+  </documentManagement>
+</p:properties>
+</file>
+
+<file path=customXml/item3.xml><?xml version="1.0" encoding="utf-8"?>
 <ct:contentTypeSchema xmlns:ct="http://schemas.microsoft.com/office/2006/metadata/contentType" xmlns:ma="http://schemas.microsoft.com/office/2006/metadata/properties/metaAttributes" ct:_="" ma:_="" ma:contentTypeName="Document" ma:contentTypeID="0x01010079F111ED35F8CC479449609E8A0923A6" ma:contentTypeVersion="11" ma:contentTypeDescription="Create a new document." ma:contentTypeScope="" ma:versionID="96291512c1ee715ab617f4c07df79fc1">
   <xsd:schema xmlns:xsd="http://www.w3.org/2001/XMLSchema" xmlns:xs="http://www.w3.org/2001/XMLSchema" xmlns:p="http://schemas.microsoft.com/office/2006/metadata/properties" xmlns:ns2="71af3243-3dd4-4a8d-8c0d-dd76da1f02a5" xmlns:ns3="16c05727-aa75-4e4a-9b5f-8a80a1165891" targetNamespace="http://schemas.microsoft.com/office/2006/metadata/properties" ma:root="true" ma:fieldsID="8256c27c40ca5c40ce1cf6c44f0205df" ns2:_="" ns3:_="">
     <xsd:import namespace="71af3243-3dd4-4a8d-8c0d-dd76da1f02a5"/>
@@ -17690,24 +17702,32 @@
 </ct:contentTypeSchema>
 </file>
 
-<file path=customXml/item2.xml><?xml version="1.0" encoding="utf-8"?>
-<?mso-contentType ?>
-<FormTemplates xmlns="http://schemas.microsoft.com/sharepoint/v3/contenttype/forms">
-  <Display>DocumentLibraryForm</Display>
-  <Edit>DocumentLibraryForm</Edit>
-  <New>DocumentLibraryForm</New>
-</FormTemplates>
+<file path=customXml/itemProps1.xml><?xml version="1.0" encoding="utf-8"?>
+<ds:datastoreItem xmlns:ds="http://schemas.openxmlformats.org/officeDocument/2006/customXml" ds:itemID="{38C25A74-1E0C-4362-AFA3-6197BD285F3A}">
+  <ds:schemaRefs>
+    <ds:schemaRef ds:uri="http://schemas.microsoft.com/sharepoint/v3/contenttype/forms"/>
+  </ds:schemaRefs>
+</ds:datastoreItem>
 </file>
 
-<file path=customXml/item3.xml><?xml version="1.0" encoding="utf-8"?>
-<p:properties xmlns:p="http://schemas.microsoft.com/office/2006/metadata/properties" xmlns:xsi="http://www.w3.org/2001/XMLSchema-instance" xmlns:pc="http://schemas.microsoft.com/office/infopath/2007/PartnerControls">
-  <documentManagement>
-    <MediaServiceKeyPoints xmlns="71af3243-3dd4-4a8d-8c0d-dd76da1f02a5" xsi:nil="true"/>
-  </documentManagement>
-</p:properties>
+<file path=customXml/itemProps2.xml><?xml version="1.0" encoding="utf-8"?>
+<ds:datastoreItem xmlns:ds="http://schemas.openxmlformats.org/officeDocument/2006/customXml" ds:itemID="{0EC94942-C689-461B-8649-1FD863C6BA2B}">
+  <ds:schemaRefs>
+    <ds:schemaRef ds:uri="http://purl.org/dc/elements/1.1/"/>
+    <ds:schemaRef ds:uri="http://schemas.microsoft.com/office/2006/metadata/properties"/>
+    <ds:schemaRef ds:uri="http://purl.org/dc/terms/"/>
+    <ds:schemaRef ds:uri="http://schemas.openxmlformats.org/package/2006/metadata/core-properties"/>
+    <ds:schemaRef ds:uri="16c05727-aa75-4e4a-9b5f-8a80a1165891"/>
+    <ds:schemaRef ds:uri="http://schemas.microsoft.com/office/2006/documentManagement/types"/>
+    <ds:schemaRef ds:uri="http://schemas.microsoft.com/office/infopath/2007/PartnerControls"/>
+    <ds:schemaRef ds:uri="71af3243-3dd4-4a8d-8c0d-dd76da1f02a5"/>
+    <ds:schemaRef ds:uri="http://www.w3.org/XML/1998/namespace"/>
+    <ds:schemaRef ds:uri="http://purl.org/dc/dcmitype/"/>
+  </ds:schemaRefs>
+</ds:datastoreItem>
 </file>
 
-<file path=customXml/itemProps1.xml><?xml version="1.0" encoding="utf-8"?>
+<file path=customXml/itemProps3.xml><?xml version="1.0" encoding="utf-8"?>
 <ds:datastoreItem xmlns:ds="http://schemas.openxmlformats.org/officeDocument/2006/customXml" ds:itemID="{096277B9-27DA-47CA-9593-62E4BB44ABEA}">
   <ds:schemaRefs>
     <ds:schemaRef ds:uri="http://schemas.microsoft.com/office/2006/metadata/contentType"/>
@@ -17724,29 +17744,4 @@
     <ds:schemaRef ds:uri="http://schemas.microsoft.com/internal/obd"/>
   </ds:schemaRefs>
 </ds:datastoreItem>
-</file>
-
-<file path=customXml/itemProps2.xml><?xml version="1.0" encoding="utf-8"?>
-<ds:datastoreItem xmlns:ds="http://schemas.openxmlformats.org/officeDocument/2006/customXml" ds:itemID="{38C25A74-1E0C-4362-AFA3-6197BD285F3A}">
-  <ds:schemaRefs>
-    <ds:schemaRef ds:uri="http://schemas.microsoft.com/sharepoint/v3/contenttype/forms"/>
-  </ds:schemaRefs>
-</ds:datastoreItem>
-</file>
-
-<file path=customXml/itemProps3.xml><?xml version="1.0" encoding="utf-8"?>
-<ds:datastoreItem xmlns:ds="http://schemas.openxmlformats.org/officeDocument/2006/customXml" ds:itemID="{0EC94942-C689-461B-8649-1FD863C6BA2B}">
-  <ds:schemaRefs>
-    <ds:schemaRef ds:uri="http://purl.org/dc/elements/1.1/"/>
-    <ds:schemaRef ds:uri="http://schemas.microsoft.com/office/2006/metadata/properties"/>
-    <ds:schemaRef ds:uri="http://purl.org/dc/terms/"/>
-    <ds:schemaRef ds:uri="http://schemas.openxmlformats.org/package/2006/metadata/core-properties"/>
-    <ds:schemaRef ds:uri="16c05727-aa75-4e4a-9b5f-8a80a1165891"/>
-    <ds:schemaRef ds:uri="http://schemas.microsoft.com/office/2006/documentManagement/types"/>
-    <ds:schemaRef ds:uri="http://schemas.microsoft.com/office/infopath/2007/PartnerControls"/>
-    <ds:schemaRef ds:uri="71af3243-3dd4-4a8d-8c0d-dd76da1f02a5"/>
-    <ds:schemaRef ds:uri="http://www.w3.org/XML/1998/namespace"/>
-    <ds:schemaRef ds:uri="http://purl.org/dc/dcmitype/"/>
-  </ds:schemaRefs>
-</ds:datastoreItem>
 </file>
</xml_diff>